<commit_message>
Slides: sessions in progress
Co-Authored-By: Claude Opus 5.5 <noreply@anthropic.com>
Claude-Session: https://claude.ai/code/session_01XkzKv8pUGMF9AsqSCMpnBq
</commit_message>
<xml_diff>
--- a/slides/decks/s05-engraftment-graft-failure.pptx
+++ b/slides/decks/s05-engraftment-graft-failure.pptx
@@ -134,26 +134,26 @@
   <p:extLst>
     <p:ext uri="{521415D9-36F7-43E2-AB2F-B90AF26B5E84}">
       <p14:sectionLst xmlns:p14="http://schemas.microsoft.com/office/powerpoint/2010/main">
-        <p14:section name="Opening" id="{98db4dbb-7176-11ea-ae01-a4976b9fc6bf}">
+        <p14:section name="Opening" id="{97abadca-0d33-e013-5eb4-f9bdca79fef8}">
           <p14:sldIdLst>
             <p14:sldId id="256"/>
             <p14:sldId id="257"/>
           </p14:sldIdLst>
         </p14:section>
-        <p14:section name="Engraftment and chimerism" id="{8b7d746b-60bc-34f1-7bd2-d9963eb571c3}">
+        <p14:section name="Engraftment and chimerism" id="{3b2edfcb-8d42-b8c1-6fea-4fc2ee5c11ab}">
           <p14:sldIdLst>
             <p14:sldId id="258"/>
             <p14:sldId id="259"/>
           </p14:sldIdLst>
         </p14:section>
-        <p14:section name="Chimerism in disease" id="{5882580d-bf98-ae35-ffe9-5702de388f98}">
+        <p14:section name="Chimerism in disease" id="{c109bf9b-1d72-05d7-1d1e-43ccfcad8045}">
           <p14:sldIdLst>
             <p14:sldId id="260"/>
             <p14:sldId id="261"/>
             <p14:sldId id="262"/>
           </p14:sldIdLst>
         </p14:section>
-        <p14:section name="Graft failure" id="{943535b1-5603-5cdb-2991-f2b80913f820}">
+        <p14:section name="Graft failure" id="{bd4fa771-7d6d-7174-a55d-58781f223595}">
           <p14:sldIdLst>
             <p14:sldId id="263"/>
             <p14:sldId id="264"/>
@@ -163,14 +163,14 @@
             <p14:sldId id="268"/>
           </p14:sldIdLst>
         </p14:section>
-        <p14:section name="Management" id="{d6968e13-2573-8a66-bc77-52d59efafde7}">
+        <p14:section name="Management" id="{d3ca125d-9601-840a-5d15-f831401ad551}">
           <p14:sldIdLst>
             <p14:sldId id="269"/>
             <p14:sldId id="270"/>
             <p14:sldId id="271"/>
           </p14:sldIdLst>
         </p14:section>
-        <p14:section name="Board questions" id="{8a5f879a-f917-5eba-4ac1-16d88dd1ed2f}">
+        <p14:section name="Board questions" id="{dc188439-8adb-3f38-6707-4fc392421af2}">
           <p14:sldIdLst>
             <p14:sldId id="272"/>
             <p14:sldId id="273"/>
@@ -180,14 +180,14 @@
             <p14:sldId id="277"/>
           </p14:sldIdLst>
         </p14:section>
-        <p14:section name="References" id="{0e047a02-66da-6a8a-1dca-d91ffd6dc310}">
+        <p14:section name="References" id="{aab83916-5588-b215-6bdc-48ed5335cba6}">
           <p14:sldIdLst>
             <p14:sldId id="278"/>
             <p14:sldId id="279"/>
             <p14:sldId id="280"/>
           </p14:sldIdLst>
         </p14:section>
-        <p14:section name="Backup" id="{0b858acd-0507-376c-96ae-dd0c5285886e}">
+        <p14:section name="Backup" id="{001688a4-ed19-9ca1-72ee-9ffe82f337e9}">
           <p14:sldIdLst>
             <p14:sldId id="281"/>
             <p14:sldId id="282"/>
@@ -17184,10 +17184,24 @@
                             <a:schemeClr val="tx1"/>
                           </a:solidFill>
                         </a:rPr>
-                        <a:t>CB 30%; PB/BM 70–75%</a:t>
+                        <a:t>CB 30%</a:t>
                       </a:r>
                       <a:endParaRPr lang="en-US" sz="1400" dirty="0"/>
                     </a:p>
+                    <a:p>
+                      <a:pPr indent="0" marL="0">
+                        <a:buNone/>
+                      </a:pPr>
+                      <a:r>
+                        <a:rPr lang="en-US" sz="1400" dirty="0">
+                          <a:solidFill>
+                            <a:schemeClr val="tx1"/>
+                          </a:solidFill>
+                        </a:rPr>
+                        <a:t>PB/BM 70–75%</a:t>
+                      </a:r>
+                      <a:endParaRPr lang="en-US" sz="1400" dirty="0"/>
+                    </a:p>
                   </a:txBody>
                   <a:tcPr marL="25400" marR="101600" marT="63500" marB="63500" anchor="ctr">
                     <a:lnL w="0" cap="flat" cmpd="sng" algn="ctr">
@@ -17224,7 +17238,21 @@
                             <a:schemeClr val="tx1"/>
                           </a:solidFill>
                         </a:rPr>
-                        <a:t>1 y: PB 58%; CB 28%</a:t>
+                        <a:t>1 y: PB 58%</a:t>
+                      </a:r>
+                      <a:endParaRPr lang="en-US" sz="1400" dirty="0"/>
+                    </a:p>
+                    <a:p>
+                      <a:pPr indent="0" marL="0">
+                        <a:buNone/>
+                      </a:pPr>
+                      <a:r>
+                        <a:rPr lang="en-US" sz="1400" dirty="0">
+                          <a:solidFill>
+                            <a:schemeClr val="tx1"/>
+                          </a:solidFill>
+                        </a:rPr>
+                        <a:t>1 y: CB 28%</a:t>
                       </a:r>
                       <a:endParaRPr lang="en-US" sz="1400" dirty="0"/>
                     </a:p>

</xml_diff>